<commit_message>
Add final application screenshots and documentation
</commit_message>
<xml_diff>
--- a/docs/presentation/SmartLoan_Analytics_Final_Presentation.pptx
+++ b/docs/presentation/SmartLoan_Analytics_Final_Presentation.pptx
@@ -1,30 +1,33 @@
 
 <file path=ppt/presentation.xml><?xml version="1.0" encoding="utf-8"?>
-<p:presentation xmlns:a="http://schemas.openxmlformats.org/drawingml/2006/main" xmlns:r="http://schemas.openxmlformats.org/officeDocument/2006/relationships" xmlns:p="http://schemas.openxmlformats.org/presentationml/2006/main" saveSubsetFonts="1" autoCompressPictures="0">
+<p:presentation xmlns:a="http://schemas.openxmlformats.org/drawingml/2006/main" xmlns:r="http://schemas.openxmlformats.org/officeDocument/2006/relationships" xmlns:p="http://schemas.openxmlformats.org/presentationml/2006/main" autoCompressPictures="0">
   <p:sldMasterIdLst>
     <p:sldMasterId id="2147483648" r:id="rId1"/>
   </p:sldMasterIdLst>
+  <p:notesMasterIdLst>
+    <p:notesMasterId r:id="rId4"/>
+  </p:notesMasterIdLst>
   <p:sldIdLst>
-    <p:sldId id="256" r:id="rId7"/>
-    <p:sldId id="257" r:id="rId9"/>
-    <p:sldId id="258" r:id="rId10"/>
-    <p:sldId id="259" r:id="rId11"/>
-    <p:sldId id="260" r:id="rId12"/>
-    <p:sldId id="261" r:id="rId13"/>
-    <p:sldId id="262" r:id="rId14"/>
-    <p:sldId id="263" r:id="rId15"/>
-    <p:sldId id="264" r:id="rId16"/>
-    <p:sldId id="265" r:id="rId17"/>
-    <p:sldId id="266" r:id="rId18"/>
-    <p:sldId id="267" r:id="rId19"/>
-    <p:sldId id="268" r:id="rId20"/>
-    <p:sldId id="269" r:id="rId21"/>
-    <p:sldId id="270" r:id="rId22"/>
-    <p:sldId id="271" r:id="rId23"/>
-    <p:sldId id="272" r:id="rId24"/>
-    <p:sldId id="273" r:id="rId25"/>
+    <p:sldId id="256" r:id="rId3"/>
+    <p:sldId id="257" r:id="rId5"/>
+    <p:sldId id="258" r:id="rId6"/>
+    <p:sldId id="259" r:id="rId7"/>
+    <p:sldId id="260" r:id="rId8"/>
+    <p:sldId id="261" r:id="rId9"/>
+    <p:sldId id="262" r:id="rId10"/>
+    <p:sldId id="263" r:id="rId11"/>
+    <p:sldId id="264" r:id="rId12"/>
+    <p:sldId id="265" r:id="rId13"/>
+    <p:sldId id="266" r:id="rId14"/>
+    <p:sldId id="267" r:id="rId15"/>
+    <p:sldId id="268" r:id="rId16"/>
+    <p:sldId id="269" r:id="rId17"/>
+    <p:sldId id="270" r:id="rId18"/>
+    <p:sldId id="271" r:id="rId19"/>
+    <p:sldId id="272" r:id="rId20"/>
+    <p:sldId id="273" r:id="rId21"/>
   </p:sldIdLst>
-  <p:sldSz cx="12191695" cy="6858000" type="screen4x3"/>
+  <p:sldSz cx="12191365" cy="6858000" type="screen4x3"/>
   <p:notesSz cx="6858000" cy="9144000"/>
   <p:defaultTextStyle>
     <a:defPPr>
@@ -121,11 +124,27 @@
       </a:defRPr>
     </a:lvl9pPr>
   </p:defaultTextStyle>
+  <p:extLst>
+    <p:ext uri="{EFAFB233-063F-42B5-8137-9DF3F51BA10A}">
+      <p15:sldGuideLst xmlns:p15="http://schemas.microsoft.com/office/powerpoint/2012/main">
+        <p15:guide id="1" orient="horz" pos="2160" userDrawn="1">
+          <p15:clr>
+            <a:srgbClr val="A4A3A4"/>
+          </p15:clr>
+        </p15:guide>
+        <p15:guide id="2" pos="2880" userDrawn="1">
+          <p15:clr>
+            <a:srgbClr val="A4A3A4"/>
+          </p15:clr>
+        </p15:guide>
+      </p15:sldGuideLst>
+    </p:ext>
+  </p:extLst>
 </p:presentation>
 </file>
 
 <file path=ppt/notesMasters/notesMaster1.xml><?xml version="1.0" encoding="utf-8"?>
-<p:notesMaster xmlns:a="http://schemas.openxmlformats.org/drawingml/2006/main" xmlns:p="http://schemas.openxmlformats.org/presentationml/2006/main" xmlns:r="http://schemas.openxmlformats.org/officeDocument/2006/relationships">
+<p:notesMaster xmlns:a="http://schemas.openxmlformats.org/drawingml/2006/main" xmlns:r="http://schemas.openxmlformats.org/officeDocument/2006/relationships" xmlns:p="http://schemas.openxmlformats.org/presentationml/2006/main">
   <p:cSld>
     <p:bg>
       <p:bgRef idx="1001">
@@ -206,7 +225,6 @@
           <a:p>
             <a:fld id="{0F89C1C7-3DCD-1040-A9CF-14679D8B5DDD}" type="datetimeFigureOut">
               <a:rPr lang="en-US" smtClean="0"/>
-              <a:t>10/17/16</a:t>
             </a:fld>
             <a:endParaRPr lang="en-US"/>
           </a:p>
@@ -273,6 +291,7 @@
               <a:rPr lang="en-US" smtClean="0"/>
               <a:t>Click to edit Master text styles</a:t>
             </a:r>
+            <a:endParaRPr lang="en-US" smtClean="0"/>
           </a:p>
           <a:p>
             <a:pPr lvl="1"/>
@@ -280,6 +299,7 @@
               <a:rPr lang="en-US" smtClean="0"/>
               <a:t>Second level</a:t>
             </a:r>
+            <a:endParaRPr lang="en-US" smtClean="0"/>
           </a:p>
           <a:p>
             <a:pPr lvl="2"/>
@@ -287,6 +307,7 @@
               <a:rPr lang="en-US" smtClean="0"/>
               <a:t>Third level</a:t>
             </a:r>
+            <a:endParaRPr lang="en-US" smtClean="0"/>
           </a:p>
           <a:p>
             <a:pPr lvl="3"/>
@@ -294,6 +315,7 @@
               <a:rPr lang="en-US" smtClean="0"/>
               <a:t>Fourth level</a:t>
             </a:r>
+            <a:endParaRPr lang="en-US" smtClean="0"/>
           </a:p>
           <a:p>
             <a:pPr lvl="4"/>
@@ -365,18 +387,12 @@
           <a:p>
             <a:fld id="{BB5E49A5-4136-284D-997B-48E1D791AD67}" type="slidenum">
               <a:rPr lang="en-US" smtClean="0"/>
-              <a:t>‹#›</a:t>
             </a:fld>
             <a:endParaRPr lang="en-US"/>
           </a:p>
         </p:txBody>
       </p:sp>
     </p:spTree>
-    <p:extLst>
-      <p:ext uri="{BB962C8B-B14F-4D97-AF65-F5344CB8AC3E}">
-        <p14:creationId xmlns:p14="http://schemas.microsoft.com/office/powerpoint/2010/main" val="2623252185"/>
-      </p:ext>
-    </p:extLst>
   </p:cSld>
   <p:clrMap bg1="lt1" tx1="dk1" bg2="lt2" tx2="dk2" accent1="accent1" accent2="accent2" accent3="accent3" accent4="accent4" accent5="accent5" accent6="accent6" hlink="hlink" folHlink="folHlink"/>
   <p:notesStyle>
@@ -475,7 +491,7 @@
 </file>
 
 <file path=ppt/notesSlides/notesSlide1.xml><?xml version="1.0" encoding="utf-8"?>
-<p:notes xmlns:a="http://schemas.openxmlformats.org/drawingml/2006/main" xmlns:p="http://schemas.openxmlformats.org/presentationml/2006/main" xmlns:r="http://schemas.openxmlformats.org/officeDocument/2006/relationships">
+<p:notes xmlns:a="http://schemas.openxmlformats.org/drawingml/2006/main" xmlns:r="http://schemas.openxmlformats.org/officeDocument/2006/relationships" xmlns:p="http://schemas.openxmlformats.org/presentationml/2006/main">
   <p:cSld>
     <p:spTree>
       <p:nvGrpSpPr>
@@ -510,7 +526,7 @@
             <a:spLocks noGrp="1"/>
           </p:cNvSpPr>
           <p:nvPr>
-            <p:ph type="body" idx="3" sz="quarter"/>
+            <p:ph type="body" sz="quarter" idx="3"/>
           </p:nvPr>
         </p:nvSpPr>
         <p:spPr/>
@@ -531,7 +547,7 @@
             <a:spLocks noGrp="1"/>
           </p:cNvSpPr>
           <p:nvPr>
-            <p:ph type="sldNum" idx="5" sz="quarter"/>
+            <p:ph type="sldNum" sz="quarter" idx="5"/>
           </p:nvPr>
         </p:nvSpPr>
         <p:spPr/>
@@ -545,7 +561,7 @@
 </file>
 
 <file path=ppt/notesSlides/notesSlide10.xml><?xml version="1.0" encoding="utf-8"?>
-<p:notes xmlns:a="http://schemas.openxmlformats.org/drawingml/2006/main" xmlns:p="http://schemas.openxmlformats.org/presentationml/2006/main" xmlns:r="http://schemas.openxmlformats.org/officeDocument/2006/relationships">
+<p:notes xmlns:a="http://schemas.openxmlformats.org/drawingml/2006/main" xmlns:r="http://schemas.openxmlformats.org/officeDocument/2006/relationships" xmlns:p="http://schemas.openxmlformats.org/presentationml/2006/main">
   <p:cSld>
     <p:spTree>
       <p:nvGrpSpPr>
@@ -580,7 +596,7 @@
             <a:spLocks noGrp="1"/>
           </p:cNvSpPr>
           <p:nvPr>
-            <p:ph type="body" idx="3" sz="quarter"/>
+            <p:ph type="body" sz="quarter" idx="3"/>
           </p:nvPr>
         </p:nvSpPr>
         <p:spPr/>
@@ -601,7 +617,7 @@
             <a:spLocks noGrp="1"/>
           </p:cNvSpPr>
           <p:nvPr>
-            <p:ph type="sldNum" idx="5" sz="quarter"/>
+            <p:ph type="sldNum" sz="quarter" idx="5"/>
           </p:nvPr>
         </p:nvSpPr>
         <p:spPr/>
@@ -615,7 +631,7 @@
 </file>
 
 <file path=ppt/notesSlides/notesSlide11.xml><?xml version="1.0" encoding="utf-8"?>
-<p:notes xmlns:a="http://schemas.openxmlformats.org/drawingml/2006/main" xmlns:p="http://schemas.openxmlformats.org/presentationml/2006/main" xmlns:r="http://schemas.openxmlformats.org/officeDocument/2006/relationships">
+<p:notes xmlns:a="http://schemas.openxmlformats.org/drawingml/2006/main" xmlns:r="http://schemas.openxmlformats.org/officeDocument/2006/relationships" xmlns:p="http://schemas.openxmlformats.org/presentationml/2006/main">
   <p:cSld>
     <p:spTree>
       <p:nvGrpSpPr>
@@ -650,7 +666,7 @@
             <a:spLocks noGrp="1"/>
           </p:cNvSpPr>
           <p:nvPr>
-            <p:ph type="body" idx="3" sz="quarter"/>
+            <p:ph type="body" sz="quarter" idx="3"/>
           </p:nvPr>
         </p:nvSpPr>
         <p:spPr/>
@@ -671,7 +687,7 @@
             <a:spLocks noGrp="1"/>
           </p:cNvSpPr>
           <p:nvPr>
-            <p:ph type="sldNum" idx="5" sz="quarter"/>
+            <p:ph type="sldNum" sz="quarter" idx="5"/>
           </p:nvPr>
         </p:nvSpPr>
         <p:spPr/>
@@ -685,7 +701,7 @@
 </file>
 
 <file path=ppt/notesSlides/notesSlide12.xml><?xml version="1.0" encoding="utf-8"?>
-<p:notes xmlns:a="http://schemas.openxmlformats.org/drawingml/2006/main" xmlns:p="http://schemas.openxmlformats.org/presentationml/2006/main" xmlns:r="http://schemas.openxmlformats.org/officeDocument/2006/relationships">
+<p:notes xmlns:a="http://schemas.openxmlformats.org/drawingml/2006/main" xmlns:r="http://schemas.openxmlformats.org/officeDocument/2006/relationships" xmlns:p="http://schemas.openxmlformats.org/presentationml/2006/main">
   <p:cSld>
     <p:spTree>
       <p:nvGrpSpPr>
@@ -720,7 +736,7 @@
             <a:spLocks noGrp="1"/>
           </p:cNvSpPr>
           <p:nvPr>
-            <p:ph type="body" idx="3" sz="quarter"/>
+            <p:ph type="body" sz="quarter" idx="3"/>
           </p:nvPr>
         </p:nvSpPr>
         <p:spPr/>
@@ -741,7 +757,7 @@
             <a:spLocks noGrp="1"/>
           </p:cNvSpPr>
           <p:nvPr>
-            <p:ph type="sldNum" idx="5" sz="quarter"/>
+            <p:ph type="sldNum" sz="quarter" idx="5"/>
           </p:nvPr>
         </p:nvSpPr>
         <p:spPr/>
@@ -755,7 +771,7 @@
 </file>
 
 <file path=ppt/notesSlides/notesSlide13.xml><?xml version="1.0" encoding="utf-8"?>
-<p:notes xmlns:a="http://schemas.openxmlformats.org/drawingml/2006/main" xmlns:p="http://schemas.openxmlformats.org/presentationml/2006/main" xmlns:r="http://schemas.openxmlformats.org/officeDocument/2006/relationships">
+<p:notes xmlns:a="http://schemas.openxmlformats.org/drawingml/2006/main" xmlns:r="http://schemas.openxmlformats.org/officeDocument/2006/relationships" xmlns:p="http://schemas.openxmlformats.org/presentationml/2006/main">
   <p:cSld>
     <p:spTree>
       <p:nvGrpSpPr>
@@ -790,7 +806,7 @@
             <a:spLocks noGrp="1"/>
           </p:cNvSpPr>
           <p:nvPr>
-            <p:ph type="body" idx="3" sz="quarter"/>
+            <p:ph type="body" sz="quarter" idx="3"/>
           </p:nvPr>
         </p:nvSpPr>
         <p:spPr/>
@@ -811,7 +827,7 @@
             <a:spLocks noGrp="1"/>
           </p:cNvSpPr>
           <p:nvPr>
-            <p:ph type="sldNum" idx="5" sz="quarter"/>
+            <p:ph type="sldNum" sz="quarter" idx="5"/>
           </p:nvPr>
         </p:nvSpPr>
         <p:spPr/>
@@ -825,7 +841,7 @@
 </file>
 
 <file path=ppt/notesSlides/notesSlide14.xml><?xml version="1.0" encoding="utf-8"?>
-<p:notes xmlns:a="http://schemas.openxmlformats.org/drawingml/2006/main" xmlns:p="http://schemas.openxmlformats.org/presentationml/2006/main" xmlns:r="http://schemas.openxmlformats.org/officeDocument/2006/relationships">
+<p:notes xmlns:a="http://schemas.openxmlformats.org/drawingml/2006/main" xmlns:r="http://schemas.openxmlformats.org/officeDocument/2006/relationships" xmlns:p="http://schemas.openxmlformats.org/presentationml/2006/main">
   <p:cSld>
     <p:spTree>
       <p:nvGrpSpPr>
@@ -860,7 +876,7 @@
             <a:spLocks noGrp="1"/>
           </p:cNvSpPr>
           <p:nvPr>
-            <p:ph type="body" idx="3" sz="quarter"/>
+            <p:ph type="body" sz="quarter" idx="3"/>
           </p:nvPr>
         </p:nvSpPr>
         <p:spPr/>
@@ -881,7 +897,7 @@
             <a:spLocks noGrp="1"/>
           </p:cNvSpPr>
           <p:nvPr>
-            <p:ph type="sldNum" idx="5" sz="quarter"/>
+            <p:ph type="sldNum" sz="quarter" idx="5"/>
           </p:nvPr>
         </p:nvSpPr>
         <p:spPr/>
@@ -895,7 +911,7 @@
 </file>
 
 <file path=ppt/notesSlides/notesSlide15.xml><?xml version="1.0" encoding="utf-8"?>
-<p:notes xmlns:a="http://schemas.openxmlformats.org/drawingml/2006/main" xmlns:p="http://schemas.openxmlformats.org/presentationml/2006/main" xmlns:r="http://schemas.openxmlformats.org/officeDocument/2006/relationships">
+<p:notes xmlns:a="http://schemas.openxmlformats.org/drawingml/2006/main" xmlns:r="http://schemas.openxmlformats.org/officeDocument/2006/relationships" xmlns:p="http://schemas.openxmlformats.org/presentationml/2006/main">
   <p:cSld>
     <p:spTree>
       <p:nvGrpSpPr>
@@ -930,7 +946,7 @@
             <a:spLocks noGrp="1"/>
           </p:cNvSpPr>
           <p:nvPr>
-            <p:ph type="body" idx="3" sz="quarter"/>
+            <p:ph type="body" sz="quarter" idx="3"/>
           </p:nvPr>
         </p:nvSpPr>
         <p:spPr/>
@@ -951,7 +967,7 @@
             <a:spLocks noGrp="1"/>
           </p:cNvSpPr>
           <p:nvPr>
-            <p:ph type="sldNum" idx="5" sz="quarter"/>
+            <p:ph type="sldNum" sz="quarter" idx="5"/>
           </p:nvPr>
         </p:nvSpPr>
         <p:spPr/>
@@ -965,7 +981,7 @@
 </file>
 
 <file path=ppt/notesSlides/notesSlide16.xml><?xml version="1.0" encoding="utf-8"?>
-<p:notes xmlns:a="http://schemas.openxmlformats.org/drawingml/2006/main" xmlns:p="http://schemas.openxmlformats.org/presentationml/2006/main" xmlns:r="http://schemas.openxmlformats.org/officeDocument/2006/relationships">
+<p:notes xmlns:a="http://schemas.openxmlformats.org/drawingml/2006/main" xmlns:r="http://schemas.openxmlformats.org/officeDocument/2006/relationships" xmlns:p="http://schemas.openxmlformats.org/presentationml/2006/main">
   <p:cSld>
     <p:spTree>
       <p:nvGrpSpPr>
@@ -1000,7 +1016,7 @@
             <a:spLocks noGrp="1"/>
           </p:cNvSpPr>
           <p:nvPr>
-            <p:ph type="body" idx="3" sz="quarter"/>
+            <p:ph type="body" sz="quarter" idx="3"/>
           </p:nvPr>
         </p:nvSpPr>
         <p:spPr/>
@@ -1021,7 +1037,7 @@
             <a:spLocks noGrp="1"/>
           </p:cNvSpPr>
           <p:nvPr>
-            <p:ph type="sldNum" idx="5" sz="quarter"/>
+            <p:ph type="sldNum" sz="quarter" idx="5"/>
           </p:nvPr>
         </p:nvSpPr>
         <p:spPr/>
@@ -1035,7 +1051,7 @@
 </file>
 
 <file path=ppt/notesSlides/notesSlide17.xml><?xml version="1.0" encoding="utf-8"?>
-<p:notes xmlns:a="http://schemas.openxmlformats.org/drawingml/2006/main" xmlns:p="http://schemas.openxmlformats.org/presentationml/2006/main" xmlns:r="http://schemas.openxmlformats.org/officeDocument/2006/relationships">
+<p:notes xmlns:a="http://schemas.openxmlformats.org/drawingml/2006/main" xmlns:r="http://schemas.openxmlformats.org/officeDocument/2006/relationships" xmlns:p="http://schemas.openxmlformats.org/presentationml/2006/main">
   <p:cSld>
     <p:spTree>
       <p:nvGrpSpPr>
@@ -1070,7 +1086,7 @@
             <a:spLocks noGrp="1"/>
           </p:cNvSpPr>
           <p:nvPr>
-            <p:ph type="body" idx="3" sz="quarter"/>
+            <p:ph type="body" sz="quarter" idx="3"/>
           </p:nvPr>
         </p:nvSpPr>
         <p:spPr/>
@@ -1091,7 +1107,7 @@
             <a:spLocks noGrp="1"/>
           </p:cNvSpPr>
           <p:nvPr>
-            <p:ph type="sldNum" idx="5" sz="quarter"/>
+            <p:ph type="sldNum" sz="quarter" idx="5"/>
           </p:nvPr>
         </p:nvSpPr>
         <p:spPr/>
@@ -1105,7 +1121,7 @@
 </file>
 
 <file path=ppt/notesSlides/notesSlide18.xml><?xml version="1.0" encoding="utf-8"?>
-<p:notes xmlns:a="http://schemas.openxmlformats.org/drawingml/2006/main" xmlns:p="http://schemas.openxmlformats.org/presentationml/2006/main" xmlns:r="http://schemas.openxmlformats.org/officeDocument/2006/relationships">
+<p:notes xmlns:a="http://schemas.openxmlformats.org/drawingml/2006/main" xmlns:r="http://schemas.openxmlformats.org/officeDocument/2006/relationships" xmlns:p="http://schemas.openxmlformats.org/presentationml/2006/main">
   <p:cSld>
     <p:spTree>
       <p:nvGrpSpPr>
@@ -1140,7 +1156,7 @@
             <a:spLocks noGrp="1"/>
           </p:cNvSpPr>
           <p:nvPr>
-            <p:ph type="body" idx="3" sz="quarter"/>
+            <p:ph type="body" sz="quarter" idx="3"/>
           </p:nvPr>
         </p:nvSpPr>
         <p:spPr/>
@@ -1161,7 +1177,7 @@
             <a:spLocks noGrp="1"/>
           </p:cNvSpPr>
           <p:nvPr>
-            <p:ph type="sldNum" idx="5" sz="quarter"/>
+            <p:ph type="sldNum" sz="quarter" idx="5"/>
           </p:nvPr>
         </p:nvSpPr>
         <p:spPr/>
@@ -1175,7 +1191,7 @@
 </file>
 
 <file path=ppt/notesSlides/notesSlide2.xml><?xml version="1.0" encoding="utf-8"?>
-<p:notes xmlns:a="http://schemas.openxmlformats.org/drawingml/2006/main" xmlns:p="http://schemas.openxmlformats.org/presentationml/2006/main" xmlns:r="http://schemas.openxmlformats.org/officeDocument/2006/relationships">
+<p:notes xmlns:a="http://schemas.openxmlformats.org/drawingml/2006/main" xmlns:r="http://schemas.openxmlformats.org/officeDocument/2006/relationships" xmlns:p="http://schemas.openxmlformats.org/presentationml/2006/main">
   <p:cSld>
     <p:spTree>
       <p:nvGrpSpPr>
@@ -1210,7 +1226,7 @@
             <a:spLocks noGrp="1"/>
           </p:cNvSpPr>
           <p:nvPr>
-            <p:ph type="body" idx="3" sz="quarter"/>
+            <p:ph type="body" sz="quarter" idx="3"/>
           </p:nvPr>
         </p:nvSpPr>
         <p:spPr/>
@@ -1231,7 +1247,7 @@
             <a:spLocks noGrp="1"/>
           </p:cNvSpPr>
           <p:nvPr>
-            <p:ph type="sldNum" idx="5" sz="quarter"/>
+            <p:ph type="sldNum" sz="quarter" idx="5"/>
           </p:nvPr>
         </p:nvSpPr>
         <p:spPr/>
@@ -1245,7 +1261,7 @@
 </file>
 
 <file path=ppt/notesSlides/notesSlide3.xml><?xml version="1.0" encoding="utf-8"?>
-<p:notes xmlns:a="http://schemas.openxmlformats.org/drawingml/2006/main" xmlns:p="http://schemas.openxmlformats.org/presentationml/2006/main" xmlns:r="http://schemas.openxmlformats.org/officeDocument/2006/relationships">
+<p:notes xmlns:a="http://schemas.openxmlformats.org/drawingml/2006/main" xmlns:r="http://schemas.openxmlformats.org/officeDocument/2006/relationships" xmlns:p="http://schemas.openxmlformats.org/presentationml/2006/main">
   <p:cSld>
     <p:spTree>
       <p:nvGrpSpPr>
@@ -1280,7 +1296,7 @@
             <a:spLocks noGrp="1"/>
           </p:cNvSpPr>
           <p:nvPr>
-            <p:ph type="body" idx="3" sz="quarter"/>
+            <p:ph type="body" sz="quarter" idx="3"/>
           </p:nvPr>
         </p:nvSpPr>
         <p:spPr/>
@@ -1301,7 +1317,7 @@
             <a:spLocks noGrp="1"/>
           </p:cNvSpPr>
           <p:nvPr>
-            <p:ph type="sldNum" idx="5" sz="quarter"/>
+            <p:ph type="sldNum" sz="quarter" idx="5"/>
           </p:nvPr>
         </p:nvSpPr>
         <p:spPr/>
@@ -1315,7 +1331,7 @@
 </file>
 
 <file path=ppt/notesSlides/notesSlide4.xml><?xml version="1.0" encoding="utf-8"?>
-<p:notes xmlns:a="http://schemas.openxmlformats.org/drawingml/2006/main" xmlns:p="http://schemas.openxmlformats.org/presentationml/2006/main" xmlns:r="http://schemas.openxmlformats.org/officeDocument/2006/relationships">
+<p:notes xmlns:a="http://schemas.openxmlformats.org/drawingml/2006/main" xmlns:r="http://schemas.openxmlformats.org/officeDocument/2006/relationships" xmlns:p="http://schemas.openxmlformats.org/presentationml/2006/main">
   <p:cSld>
     <p:spTree>
       <p:nvGrpSpPr>
@@ -1350,7 +1366,7 @@
             <a:spLocks noGrp="1"/>
           </p:cNvSpPr>
           <p:nvPr>
-            <p:ph type="body" idx="3" sz="quarter"/>
+            <p:ph type="body" sz="quarter" idx="3"/>
           </p:nvPr>
         </p:nvSpPr>
         <p:spPr/>
@@ -1371,7 +1387,7 @@
             <a:spLocks noGrp="1"/>
           </p:cNvSpPr>
           <p:nvPr>
-            <p:ph type="sldNum" idx="5" sz="quarter"/>
+            <p:ph type="sldNum" sz="quarter" idx="5"/>
           </p:nvPr>
         </p:nvSpPr>
         <p:spPr/>
@@ -1385,7 +1401,7 @@
 </file>
 
 <file path=ppt/notesSlides/notesSlide5.xml><?xml version="1.0" encoding="utf-8"?>
-<p:notes xmlns:a="http://schemas.openxmlformats.org/drawingml/2006/main" xmlns:p="http://schemas.openxmlformats.org/presentationml/2006/main" xmlns:r="http://schemas.openxmlformats.org/officeDocument/2006/relationships">
+<p:notes xmlns:a="http://schemas.openxmlformats.org/drawingml/2006/main" xmlns:r="http://schemas.openxmlformats.org/officeDocument/2006/relationships" xmlns:p="http://schemas.openxmlformats.org/presentationml/2006/main">
   <p:cSld>
     <p:spTree>
       <p:nvGrpSpPr>
@@ -1420,7 +1436,7 @@
             <a:spLocks noGrp="1"/>
           </p:cNvSpPr>
           <p:nvPr>
-            <p:ph type="body" idx="3" sz="quarter"/>
+            <p:ph type="body" sz="quarter" idx="3"/>
           </p:nvPr>
         </p:nvSpPr>
         <p:spPr/>
@@ -1441,7 +1457,7 @@
             <a:spLocks noGrp="1"/>
           </p:cNvSpPr>
           <p:nvPr>
-            <p:ph type="sldNum" idx="5" sz="quarter"/>
+            <p:ph type="sldNum" sz="quarter" idx="5"/>
           </p:nvPr>
         </p:nvSpPr>
         <p:spPr/>
@@ -1455,7 +1471,7 @@
 </file>
 
 <file path=ppt/notesSlides/notesSlide6.xml><?xml version="1.0" encoding="utf-8"?>
-<p:notes xmlns:a="http://schemas.openxmlformats.org/drawingml/2006/main" xmlns:p="http://schemas.openxmlformats.org/presentationml/2006/main" xmlns:r="http://schemas.openxmlformats.org/officeDocument/2006/relationships">
+<p:notes xmlns:a="http://schemas.openxmlformats.org/drawingml/2006/main" xmlns:r="http://schemas.openxmlformats.org/officeDocument/2006/relationships" xmlns:p="http://schemas.openxmlformats.org/presentationml/2006/main">
   <p:cSld>
     <p:spTree>
       <p:nvGrpSpPr>
@@ -1490,7 +1506,7 @@
             <a:spLocks noGrp="1"/>
           </p:cNvSpPr>
           <p:nvPr>
-            <p:ph type="body" idx="3" sz="quarter"/>
+            <p:ph type="body" sz="quarter" idx="3"/>
           </p:nvPr>
         </p:nvSpPr>
         <p:spPr/>
@@ -1511,7 +1527,7 @@
             <a:spLocks noGrp="1"/>
           </p:cNvSpPr>
           <p:nvPr>
-            <p:ph type="sldNum" idx="5" sz="quarter"/>
+            <p:ph type="sldNum" sz="quarter" idx="5"/>
           </p:nvPr>
         </p:nvSpPr>
         <p:spPr/>
@@ -1525,7 +1541,7 @@
 </file>
 
 <file path=ppt/notesSlides/notesSlide7.xml><?xml version="1.0" encoding="utf-8"?>
-<p:notes xmlns:a="http://schemas.openxmlformats.org/drawingml/2006/main" xmlns:p="http://schemas.openxmlformats.org/presentationml/2006/main" xmlns:r="http://schemas.openxmlformats.org/officeDocument/2006/relationships">
+<p:notes xmlns:a="http://schemas.openxmlformats.org/drawingml/2006/main" xmlns:r="http://schemas.openxmlformats.org/officeDocument/2006/relationships" xmlns:p="http://schemas.openxmlformats.org/presentationml/2006/main">
   <p:cSld>
     <p:spTree>
       <p:nvGrpSpPr>
@@ -1560,7 +1576,7 @@
             <a:spLocks noGrp="1"/>
           </p:cNvSpPr>
           <p:nvPr>
-            <p:ph type="body" idx="3" sz="quarter"/>
+            <p:ph type="body" sz="quarter" idx="3"/>
           </p:nvPr>
         </p:nvSpPr>
         <p:spPr/>
@@ -1581,7 +1597,7 @@
             <a:spLocks noGrp="1"/>
           </p:cNvSpPr>
           <p:nvPr>
-            <p:ph type="sldNum" idx="5" sz="quarter"/>
+            <p:ph type="sldNum" sz="quarter" idx="5"/>
           </p:nvPr>
         </p:nvSpPr>
         <p:spPr/>
@@ -1595,7 +1611,7 @@
 </file>
 
 <file path=ppt/notesSlides/notesSlide8.xml><?xml version="1.0" encoding="utf-8"?>
-<p:notes xmlns:a="http://schemas.openxmlformats.org/drawingml/2006/main" xmlns:p="http://schemas.openxmlformats.org/presentationml/2006/main" xmlns:r="http://schemas.openxmlformats.org/officeDocument/2006/relationships">
+<p:notes xmlns:a="http://schemas.openxmlformats.org/drawingml/2006/main" xmlns:r="http://schemas.openxmlformats.org/officeDocument/2006/relationships" xmlns:p="http://schemas.openxmlformats.org/presentationml/2006/main">
   <p:cSld>
     <p:spTree>
       <p:nvGrpSpPr>
@@ -1630,7 +1646,7 @@
             <a:spLocks noGrp="1"/>
           </p:cNvSpPr>
           <p:nvPr>
-            <p:ph type="body" idx="3" sz="quarter"/>
+            <p:ph type="body" sz="quarter" idx="3"/>
           </p:nvPr>
         </p:nvSpPr>
         <p:spPr/>
@@ -1651,7 +1667,7 @@
             <a:spLocks noGrp="1"/>
           </p:cNvSpPr>
           <p:nvPr>
-            <p:ph type="sldNum" idx="5" sz="quarter"/>
+            <p:ph type="sldNum" sz="quarter" idx="5"/>
           </p:nvPr>
         </p:nvSpPr>
         <p:spPr/>
@@ -1665,7 +1681,7 @@
 </file>
 
 <file path=ppt/notesSlides/notesSlide9.xml><?xml version="1.0" encoding="utf-8"?>
-<p:notes xmlns:a="http://schemas.openxmlformats.org/drawingml/2006/main" xmlns:p="http://schemas.openxmlformats.org/presentationml/2006/main" xmlns:r="http://schemas.openxmlformats.org/officeDocument/2006/relationships">
+<p:notes xmlns:a="http://schemas.openxmlformats.org/drawingml/2006/main" xmlns:r="http://schemas.openxmlformats.org/officeDocument/2006/relationships" xmlns:p="http://schemas.openxmlformats.org/presentationml/2006/main">
   <p:cSld>
     <p:spTree>
       <p:nvGrpSpPr>
@@ -1700,7 +1716,7 @@
             <a:spLocks noGrp="1"/>
           </p:cNvSpPr>
           <p:nvPr>
-            <p:ph type="body" idx="3" sz="quarter"/>
+            <p:ph type="body" sz="quarter" idx="3"/>
           </p:nvPr>
         </p:nvSpPr>
         <p:spPr/>
@@ -1721,7 +1737,7 @@
             <a:spLocks noGrp="1"/>
           </p:cNvSpPr>
           <p:nvPr>
-            <p:ph type="sldNum" idx="5" sz="quarter"/>
+            <p:ph type="sldNum" sz="quarter" idx="5"/>
           </p:nvPr>
         </p:nvSpPr>
         <p:spPr/>
@@ -1915,7 +1931,6 @@
           <a:p>
             <a:fld id="{5BCAD085-E8A6-8845-BD4E-CB4CCA059FC4}" type="datetimeFigureOut">
               <a:rPr lang="en-US" smtClean="0"/>
-              <a:t>1/27/13</a:t>
             </a:fld>
             <a:endParaRPr lang="en-US"/>
           </a:p>
@@ -1957,18 +1972,12 @@
           <a:p>
             <a:fld id="{C1FF6DA9-008F-8B48-92A6-B652298478BF}" type="slidenum">
               <a:rPr lang="en-US" smtClean="0"/>
-              <a:t>‹#›</a:t>
             </a:fld>
             <a:endParaRPr lang="en-US"/>
           </a:p>
         </p:txBody>
       </p:sp>
     </p:spTree>
-    <p:extLst>
-      <p:ext uri="{BB962C8B-B14F-4D97-AF65-F5344CB8AC3E}">
-        <p14:creationId xmlns:p14="http://schemas.microsoft.com/office/powerpoint/2010/main" val="3168075583"/>
-      </p:ext>
-    </p:extLst>
   </p:cSld>
   <p:clrMapOvr>
     <a:masterClrMapping/>
@@ -2036,6 +2045,7 @@
               <a:rPr lang="en-US" smtClean="0"/>
               <a:t>Click to edit Master text styles</a:t>
             </a:r>
+            <a:endParaRPr lang="en-US" smtClean="0"/>
           </a:p>
           <a:p>
             <a:pPr lvl="1"/>
@@ -2043,6 +2053,7 @@
               <a:rPr lang="en-US" smtClean="0"/>
               <a:t>Second level</a:t>
             </a:r>
+            <a:endParaRPr lang="en-US" smtClean="0"/>
           </a:p>
           <a:p>
             <a:pPr lvl="2"/>
@@ -2050,6 +2061,7 @@
               <a:rPr lang="en-US" smtClean="0"/>
               <a:t>Third level</a:t>
             </a:r>
+            <a:endParaRPr lang="en-US" smtClean="0"/>
           </a:p>
           <a:p>
             <a:pPr lvl="3"/>
@@ -2057,6 +2069,7 @@
               <a:rPr lang="en-US" smtClean="0"/>
               <a:t>Fourth level</a:t>
             </a:r>
+            <a:endParaRPr lang="en-US" smtClean="0"/>
           </a:p>
           <a:p>
             <a:pPr lvl="4"/>
@@ -2085,7 +2098,6 @@
           <a:p>
             <a:fld id="{5BCAD085-E8A6-8845-BD4E-CB4CCA059FC4}" type="datetimeFigureOut">
               <a:rPr lang="en-US" smtClean="0"/>
-              <a:t>1/27/13</a:t>
             </a:fld>
             <a:endParaRPr lang="en-US"/>
           </a:p>
@@ -2127,18 +2139,12 @@
           <a:p>
             <a:fld id="{C1FF6DA9-008F-8B48-92A6-B652298478BF}" type="slidenum">
               <a:rPr lang="en-US" smtClean="0"/>
-              <a:t>‹#›</a:t>
             </a:fld>
             <a:endParaRPr lang="en-US"/>
           </a:p>
         </p:txBody>
       </p:sp>
     </p:spTree>
-    <p:extLst>
-      <p:ext uri="{BB962C8B-B14F-4D97-AF65-F5344CB8AC3E}">
-        <p14:creationId xmlns:p14="http://schemas.microsoft.com/office/powerpoint/2010/main" val="2910927964"/>
-      </p:ext>
-    </p:extLst>
   </p:cSld>
   <p:clrMapOvr>
     <a:masterClrMapping/>
@@ -2216,6 +2222,7 @@
               <a:rPr lang="en-US" smtClean="0"/>
               <a:t>Click to edit Master text styles</a:t>
             </a:r>
+            <a:endParaRPr lang="en-US" smtClean="0"/>
           </a:p>
           <a:p>
             <a:pPr lvl="1"/>
@@ -2223,6 +2230,7 @@
               <a:rPr lang="en-US" smtClean="0"/>
               <a:t>Second level</a:t>
             </a:r>
+            <a:endParaRPr lang="en-US" smtClean="0"/>
           </a:p>
           <a:p>
             <a:pPr lvl="2"/>
@@ -2230,6 +2238,7 @@
               <a:rPr lang="en-US" smtClean="0"/>
               <a:t>Third level</a:t>
             </a:r>
+            <a:endParaRPr lang="en-US" smtClean="0"/>
           </a:p>
           <a:p>
             <a:pPr lvl="3"/>
@@ -2237,6 +2246,7 @@
               <a:rPr lang="en-US" smtClean="0"/>
               <a:t>Fourth level</a:t>
             </a:r>
+            <a:endParaRPr lang="en-US" smtClean="0"/>
           </a:p>
           <a:p>
             <a:pPr lvl="4"/>
@@ -2265,7 +2275,6 @@
           <a:p>
             <a:fld id="{5BCAD085-E8A6-8845-BD4E-CB4CCA059FC4}" type="datetimeFigureOut">
               <a:rPr lang="en-US" smtClean="0"/>
-              <a:t>1/27/13</a:t>
             </a:fld>
             <a:endParaRPr lang="en-US"/>
           </a:p>
@@ -2307,18 +2316,12 @@
           <a:p>
             <a:fld id="{C1FF6DA9-008F-8B48-92A6-B652298478BF}" type="slidenum">
               <a:rPr lang="en-US" smtClean="0"/>
-              <a:t>‹#›</a:t>
             </a:fld>
             <a:endParaRPr lang="en-US"/>
           </a:p>
         </p:txBody>
       </p:sp>
     </p:spTree>
-    <p:extLst>
-      <p:ext uri="{BB962C8B-B14F-4D97-AF65-F5344CB8AC3E}">
-        <p14:creationId xmlns:p14="http://schemas.microsoft.com/office/powerpoint/2010/main" val="3612223792"/>
-      </p:ext>
-    </p:extLst>
   </p:cSld>
   <p:clrMapOvr>
     <a:masterClrMapping/>
@@ -2386,6 +2389,7 @@
               <a:rPr lang="en-US" smtClean="0"/>
               <a:t>Click to edit Master text styles</a:t>
             </a:r>
+            <a:endParaRPr lang="en-US" smtClean="0"/>
           </a:p>
           <a:p>
             <a:pPr lvl="1"/>
@@ -2393,6 +2397,7 @@
               <a:rPr lang="en-US" smtClean="0"/>
               <a:t>Second level</a:t>
             </a:r>
+            <a:endParaRPr lang="en-US" smtClean="0"/>
           </a:p>
           <a:p>
             <a:pPr lvl="2"/>
@@ -2400,6 +2405,7 @@
               <a:rPr lang="en-US" smtClean="0"/>
               <a:t>Third level</a:t>
             </a:r>
+            <a:endParaRPr lang="en-US" smtClean="0"/>
           </a:p>
           <a:p>
             <a:pPr lvl="3"/>
@@ -2407,6 +2413,7 @@
               <a:rPr lang="en-US" smtClean="0"/>
               <a:t>Fourth level</a:t>
             </a:r>
+            <a:endParaRPr lang="en-US" smtClean="0"/>
           </a:p>
           <a:p>
             <a:pPr lvl="4"/>
@@ -2435,7 +2442,6 @@
           <a:p>
             <a:fld id="{5BCAD085-E8A6-8845-BD4E-CB4CCA059FC4}" type="datetimeFigureOut">
               <a:rPr lang="en-US" smtClean="0"/>
-              <a:t>1/27/13</a:t>
             </a:fld>
             <a:endParaRPr lang="en-US"/>
           </a:p>
@@ -2477,18 +2483,12 @@
           <a:p>
             <a:fld id="{C1FF6DA9-008F-8B48-92A6-B652298478BF}" type="slidenum">
               <a:rPr lang="en-US" smtClean="0"/>
-              <a:t>‹#›</a:t>
             </a:fld>
             <a:endParaRPr lang="en-US"/>
           </a:p>
         </p:txBody>
       </p:sp>
     </p:spTree>
-    <p:extLst>
-      <p:ext uri="{BB962C8B-B14F-4D97-AF65-F5344CB8AC3E}">
-        <p14:creationId xmlns:p14="http://schemas.microsoft.com/office/powerpoint/2010/main" val="2614314258"/>
-      </p:ext>
-    </p:extLst>
   </p:cSld>
   <p:clrMapOvr>
     <a:masterClrMapping/>
@@ -2661,6 +2661,7 @@
               <a:rPr lang="en-US" smtClean="0"/>
               <a:t>Click to edit Master text styles</a:t>
             </a:r>
+            <a:endParaRPr lang="en-US" smtClean="0"/>
           </a:p>
         </p:txBody>
       </p:sp>
@@ -2681,7 +2682,6 @@
           <a:p>
             <a:fld id="{5BCAD085-E8A6-8845-BD4E-CB4CCA059FC4}" type="datetimeFigureOut">
               <a:rPr lang="en-US" smtClean="0"/>
-              <a:t>1/27/13</a:t>
             </a:fld>
             <a:endParaRPr lang="en-US"/>
           </a:p>
@@ -2723,18 +2723,12 @@
           <a:p>
             <a:fld id="{C1FF6DA9-008F-8B48-92A6-B652298478BF}" type="slidenum">
               <a:rPr lang="en-US" smtClean="0"/>
-              <a:t>‹#›</a:t>
             </a:fld>
             <a:endParaRPr lang="en-US"/>
           </a:p>
         </p:txBody>
       </p:sp>
     </p:spTree>
-    <p:extLst>
-      <p:ext uri="{BB962C8B-B14F-4D97-AF65-F5344CB8AC3E}">
-        <p14:creationId xmlns:p14="http://schemas.microsoft.com/office/powerpoint/2010/main" val="960648375"/>
-      </p:ext>
-    </p:extLst>
   </p:cSld>
   <p:clrMapOvr>
     <a:masterClrMapping/>
@@ -2835,6 +2829,7 @@
               <a:rPr lang="en-US" smtClean="0"/>
               <a:t>Click to edit Master text styles</a:t>
             </a:r>
+            <a:endParaRPr lang="en-US" smtClean="0"/>
           </a:p>
           <a:p>
             <a:pPr lvl="1"/>
@@ -2842,6 +2837,7 @@
               <a:rPr lang="en-US" smtClean="0"/>
               <a:t>Second level</a:t>
             </a:r>
+            <a:endParaRPr lang="en-US" smtClean="0"/>
           </a:p>
           <a:p>
             <a:pPr lvl="2"/>
@@ -2849,6 +2845,7 @@
               <a:rPr lang="en-US" smtClean="0"/>
               <a:t>Third level</a:t>
             </a:r>
+            <a:endParaRPr lang="en-US" smtClean="0"/>
           </a:p>
           <a:p>
             <a:pPr lvl="3"/>
@@ -2856,6 +2853,7 @@
               <a:rPr lang="en-US" smtClean="0"/>
               <a:t>Fourth level</a:t>
             </a:r>
+            <a:endParaRPr lang="en-US" smtClean="0"/>
           </a:p>
           <a:p>
             <a:pPr lvl="4"/>
@@ -2920,6 +2918,7 @@
               <a:rPr lang="en-US" smtClean="0"/>
               <a:t>Click to edit Master text styles</a:t>
             </a:r>
+            <a:endParaRPr lang="en-US" smtClean="0"/>
           </a:p>
           <a:p>
             <a:pPr lvl="1"/>
@@ -2927,6 +2926,7 @@
               <a:rPr lang="en-US" smtClean="0"/>
               <a:t>Second level</a:t>
             </a:r>
+            <a:endParaRPr lang="en-US" smtClean="0"/>
           </a:p>
           <a:p>
             <a:pPr lvl="2"/>
@@ -2934,6 +2934,7 @@
               <a:rPr lang="en-US" smtClean="0"/>
               <a:t>Third level</a:t>
             </a:r>
+            <a:endParaRPr lang="en-US" smtClean="0"/>
           </a:p>
           <a:p>
             <a:pPr lvl="3"/>
@@ -2941,6 +2942,7 @@
               <a:rPr lang="en-US" smtClean="0"/>
               <a:t>Fourth level</a:t>
             </a:r>
+            <a:endParaRPr lang="en-US" smtClean="0"/>
           </a:p>
           <a:p>
             <a:pPr lvl="4"/>
@@ -2969,7 +2971,6 @@
           <a:p>
             <a:fld id="{5BCAD085-E8A6-8845-BD4E-CB4CCA059FC4}" type="datetimeFigureOut">
               <a:rPr lang="en-US" smtClean="0"/>
-              <a:t>1/27/13</a:t>
             </a:fld>
             <a:endParaRPr lang="en-US"/>
           </a:p>
@@ -3011,18 +3012,12 @@
           <a:p>
             <a:fld id="{C1FF6DA9-008F-8B48-92A6-B652298478BF}" type="slidenum">
               <a:rPr lang="en-US" smtClean="0"/>
-              <a:t>‹#›</a:t>
             </a:fld>
             <a:endParaRPr lang="en-US"/>
           </a:p>
         </p:txBody>
       </p:sp>
     </p:spTree>
-    <p:extLst>
-      <p:ext uri="{BB962C8B-B14F-4D97-AF65-F5344CB8AC3E}">
-        <p14:creationId xmlns:p14="http://schemas.microsoft.com/office/powerpoint/2010/main" val="2782244947"/>
-      </p:ext>
-    </p:extLst>
   </p:cSld>
   <p:clrMapOvr>
     <a:masterClrMapping/>
@@ -3136,6 +3131,7 @@
               <a:rPr lang="en-US" smtClean="0"/>
               <a:t>Click to edit Master text styles</a:t>
             </a:r>
+            <a:endParaRPr lang="en-US" smtClean="0"/>
           </a:p>
         </p:txBody>
       </p:sp>
@@ -3192,6 +3188,7 @@
               <a:rPr lang="en-US" smtClean="0"/>
               <a:t>Click to edit Master text styles</a:t>
             </a:r>
+            <a:endParaRPr lang="en-US" smtClean="0"/>
           </a:p>
           <a:p>
             <a:pPr lvl="1"/>
@@ -3199,6 +3196,7 @@
               <a:rPr lang="en-US" smtClean="0"/>
               <a:t>Second level</a:t>
             </a:r>
+            <a:endParaRPr lang="en-US" smtClean="0"/>
           </a:p>
           <a:p>
             <a:pPr lvl="2"/>
@@ -3206,6 +3204,7 @@
               <a:rPr lang="en-US" smtClean="0"/>
               <a:t>Third level</a:t>
             </a:r>
+            <a:endParaRPr lang="en-US" smtClean="0"/>
           </a:p>
           <a:p>
             <a:pPr lvl="3"/>
@@ -3213,6 +3212,7 @@
               <a:rPr lang="en-US" smtClean="0"/>
               <a:t>Fourth level</a:t>
             </a:r>
+            <a:endParaRPr lang="en-US" smtClean="0"/>
           </a:p>
           <a:p>
             <a:pPr lvl="4"/>
@@ -3286,6 +3286,7 @@
               <a:rPr lang="en-US" smtClean="0"/>
               <a:t>Click to edit Master text styles</a:t>
             </a:r>
+            <a:endParaRPr lang="en-US" smtClean="0"/>
           </a:p>
         </p:txBody>
       </p:sp>
@@ -3342,6 +3343,7 @@
               <a:rPr lang="en-US" smtClean="0"/>
               <a:t>Click to edit Master text styles</a:t>
             </a:r>
+            <a:endParaRPr lang="en-US" smtClean="0"/>
           </a:p>
           <a:p>
             <a:pPr lvl="1"/>
@@ -3349,6 +3351,7 @@
               <a:rPr lang="en-US" smtClean="0"/>
               <a:t>Second level</a:t>
             </a:r>
+            <a:endParaRPr lang="en-US" smtClean="0"/>
           </a:p>
           <a:p>
             <a:pPr lvl="2"/>
@@ -3356,6 +3359,7 @@
               <a:rPr lang="en-US" smtClean="0"/>
               <a:t>Third level</a:t>
             </a:r>
+            <a:endParaRPr lang="en-US" smtClean="0"/>
           </a:p>
           <a:p>
             <a:pPr lvl="3"/>
@@ -3363,6 +3367,7 @@
               <a:rPr lang="en-US" smtClean="0"/>
               <a:t>Fourth level</a:t>
             </a:r>
+            <a:endParaRPr lang="en-US" smtClean="0"/>
           </a:p>
           <a:p>
             <a:pPr lvl="4"/>
@@ -3391,7 +3396,6 @@
           <a:p>
             <a:fld id="{5BCAD085-E8A6-8845-BD4E-CB4CCA059FC4}" type="datetimeFigureOut">
               <a:rPr lang="en-US" smtClean="0"/>
-              <a:t>1/27/13</a:t>
             </a:fld>
             <a:endParaRPr lang="en-US"/>
           </a:p>
@@ -3433,18 +3437,12 @@
           <a:p>
             <a:fld id="{C1FF6DA9-008F-8B48-92A6-B652298478BF}" type="slidenum">
               <a:rPr lang="en-US" smtClean="0"/>
-              <a:t>‹#›</a:t>
             </a:fld>
             <a:endParaRPr lang="en-US"/>
           </a:p>
         </p:txBody>
       </p:sp>
     </p:spTree>
-    <p:extLst>
-      <p:ext uri="{BB962C8B-B14F-4D97-AF65-F5344CB8AC3E}">
-        <p14:creationId xmlns:p14="http://schemas.microsoft.com/office/powerpoint/2010/main" val="990158736"/>
-      </p:ext>
-    </p:extLst>
   </p:cSld>
   <p:clrMapOvr>
     <a:masterClrMapping/>
@@ -3509,7 +3507,6 @@
           <a:p>
             <a:fld id="{5BCAD085-E8A6-8845-BD4E-CB4CCA059FC4}" type="datetimeFigureOut">
               <a:rPr lang="en-US" smtClean="0"/>
-              <a:t>1/27/13</a:t>
             </a:fld>
             <a:endParaRPr lang="en-US"/>
           </a:p>
@@ -3551,18 +3548,12 @@
           <a:p>
             <a:fld id="{C1FF6DA9-008F-8B48-92A6-B652298478BF}" type="slidenum">
               <a:rPr lang="en-US" smtClean="0"/>
-              <a:t>‹#›</a:t>
             </a:fld>
             <a:endParaRPr lang="en-US"/>
           </a:p>
         </p:txBody>
       </p:sp>
     </p:spTree>
-    <p:extLst>
-      <p:ext uri="{BB962C8B-B14F-4D97-AF65-F5344CB8AC3E}">
-        <p14:creationId xmlns:p14="http://schemas.microsoft.com/office/powerpoint/2010/main" val="727027711"/>
-      </p:ext>
-    </p:extLst>
   </p:cSld>
   <p:clrMapOvr>
     <a:masterClrMapping/>
@@ -3604,7 +3595,6 @@
           <a:p>
             <a:fld id="{5BCAD085-E8A6-8845-BD4E-CB4CCA059FC4}" type="datetimeFigureOut">
               <a:rPr lang="en-US" smtClean="0"/>
-              <a:t>1/27/13</a:t>
             </a:fld>
             <a:endParaRPr lang="en-US"/>
           </a:p>
@@ -3646,18 +3636,12 @@
           <a:p>
             <a:fld id="{C1FF6DA9-008F-8B48-92A6-B652298478BF}" type="slidenum">
               <a:rPr lang="en-US" smtClean="0"/>
-              <a:t>‹#›</a:t>
             </a:fld>
             <a:endParaRPr lang="en-US"/>
           </a:p>
         </p:txBody>
       </p:sp>
     </p:spTree>
-    <p:extLst>
-      <p:ext uri="{BB962C8B-B14F-4D97-AF65-F5344CB8AC3E}">
-        <p14:creationId xmlns:p14="http://schemas.microsoft.com/office/powerpoint/2010/main" val="1212999818"/>
-      </p:ext>
-    </p:extLst>
   </p:cSld>
   <p:clrMapOvr>
     <a:masterClrMapping/>
@@ -3767,6 +3751,7 @@
               <a:rPr lang="en-US" smtClean="0"/>
               <a:t>Click to edit Master text styles</a:t>
             </a:r>
+            <a:endParaRPr lang="en-US" smtClean="0"/>
           </a:p>
           <a:p>
             <a:pPr lvl="1"/>
@@ -3774,6 +3759,7 @@
               <a:rPr lang="en-US" smtClean="0"/>
               <a:t>Second level</a:t>
             </a:r>
+            <a:endParaRPr lang="en-US" smtClean="0"/>
           </a:p>
           <a:p>
             <a:pPr lvl="2"/>
@@ -3781,6 +3767,7 @@
               <a:rPr lang="en-US" smtClean="0"/>
               <a:t>Third level</a:t>
             </a:r>
+            <a:endParaRPr lang="en-US" smtClean="0"/>
           </a:p>
           <a:p>
             <a:pPr lvl="3"/>
@@ -3788,6 +3775,7 @@
               <a:rPr lang="en-US" smtClean="0"/>
               <a:t>Fourth level</a:t>
             </a:r>
+            <a:endParaRPr lang="en-US" smtClean="0"/>
           </a:p>
           <a:p>
             <a:pPr lvl="4"/>
@@ -3861,6 +3849,7 @@
               <a:rPr lang="en-US" smtClean="0"/>
               <a:t>Click to edit Master text styles</a:t>
             </a:r>
+            <a:endParaRPr lang="en-US" smtClean="0"/>
           </a:p>
         </p:txBody>
       </p:sp>
@@ -3881,7 +3870,6 @@
           <a:p>
             <a:fld id="{5BCAD085-E8A6-8845-BD4E-CB4CCA059FC4}" type="datetimeFigureOut">
               <a:rPr lang="en-US" smtClean="0"/>
-              <a:t>1/27/13</a:t>
             </a:fld>
             <a:endParaRPr lang="en-US"/>
           </a:p>
@@ -3923,18 +3911,12 @@
           <a:p>
             <a:fld id="{C1FF6DA9-008F-8B48-92A6-B652298478BF}" type="slidenum">
               <a:rPr lang="en-US" smtClean="0"/>
-              <a:t>‹#›</a:t>
             </a:fld>
             <a:endParaRPr lang="en-US"/>
           </a:p>
         </p:txBody>
       </p:sp>
     </p:spTree>
-    <p:extLst>
-      <p:ext uri="{BB962C8B-B14F-4D97-AF65-F5344CB8AC3E}">
-        <p14:creationId xmlns:p14="http://schemas.microsoft.com/office/powerpoint/2010/main" val="1840726560"/>
-      </p:ext>
-    </p:extLst>
   </p:cSld>
   <p:clrMapOvr>
     <a:masterClrMapping/>
@@ -4114,6 +4096,7 @@
               <a:rPr lang="en-US" smtClean="0"/>
               <a:t>Click to edit Master text styles</a:t>
             </a:r>
+            <a:endParaRPr lang="en-US" smtClean="0"/>
           </a:p>
         </p:txBody>
       </p:sp>
@@ -4134,7 +4117,6 @@
           <a:p>
             <a:fld id="{5BCAD085-E8A6-8845-BD4E-CB4CCA059FC4}" type="datetimeFigureOut">
               <a:rPr lang="en-US" smtClean="0"/>
-              <a:t>1/27/13</a:t>
             </a:fld>
             <a:endParaRPr lang="en-US"/>
           </a:p>
@@ -4176,18 +4158,12 @@
           <a:p>
             <a:fld id="{C1FF6DA9-008F-8B48-92A6-B652298478BF}" type="slidenum">
               <a:rPr lang="en-US" smtClean="0"/>
-              <a:t>‹#›</a:t>
             </a:fld>
             <a:endParaRPr lang="en-US"/>
           </a:p>
         </p:txBody>
       </p:sp>
     </p:spTree>
-    <p:extLst>
-      <p:ext uri="{BB962C8B-B14F-4D97-AF65-F5344CB8AC3E}">
-        <p14:creationId xmlns:p14="http://schemas.microsoft.com/office/powerpoint/2010/main" val="3889236939"/>
-      </p:ext>
-    </p:extLst>
   </p:cSld>
   <p:clrMapOvr>
     <a:masterClrMapping/>
@@ -4280,6 +4256,7 @@
               <a:rPr lang="en-US" smtClean="0"/>
               <a:t>Click to edit Master text styles</a:t>
             </a:r>
+            <a:endParaRPr lang="en-US" smtClean="0"/>
           </a:p>
           <a:p>
             <a:pPr lvl="1"/>
@@ -4287,6 +4264,7 @@
               <a:rPr lang="en-US" smtClean="0"/>
               <a:t>Second level</a:t>
             </a:r>
+            <a:endParaRPr lang="en-US" smtClean="0"/>
           </a:p>
           <a:p>
             <a:pPr lvl="2"/>
@@ -4294,6 +4272,7 @@
               <a:rPr lang="en-US" smtClean="0"/>
               <a:t>Third level</a:t>
             </a:r>
+            <a:endParaRPr lang="en-US" smtClean="0"/>
           </a:p>
           <a:p>
             <a:pPr lvl="3"/>
@@ -4301,6 +4280,7 @@
               <a:rPr lang="en-US" smtClean="0"/>
               <a:t>Fourth level</a:t>
             </a:r>
+            <a:endParaRPr lang="en-US" smtClean="0"/>
           </a:p>
           <a:p>
             <a:pPr lvl="4"/>
@@ -4347,7 +4327,6 @@
           <a:p>
             <a:fld id="{5BCAD085-E8A6-8845-BD4E-CB4CCA059FC4}" type="datetimeFigureOut">
               <a:rPr lang="en-US" smtClean="0"/>
-              <a:t>1/27/13</a:t>
             </a:fld>
             <a:endParaRPr lang="en-US"/>
           </a:p>
@@ -4425,18 +4404,12 @@
           <a:p>
             <a:fld id="{C1FF6DA9-008F-8B48-92A6-B652298478BF}" type="slidenum">
               <a:rPr lang="en-US" smtClean="0"/>
-              <a:t>‹#›</a:t>
             </a:fld>
             <a:endParaRPr lang="en-US"/>
           </a:p>
         </p:txBody>
       </p:sp>
     </p:spTree>
-    <p:extLst>
-      <p:ext uri="{BB962C8B-B14F-4D97-AF65-F5344CB8AC3E}">
-        <p14:creationId xmlns:p14="http://schemas.microsoft.com/office/powerpoint/2010/main" val="2209977519"/>
-      </p:ext>
-    </p:extLst>
   </p:cSld>
   <p:clrMap bg1="lt1" tx1="dk1" bg2="lt2" tx2="dk2" accent1="accent1" accent2="accent2" accent3="accent3" accent4="accent4" accent5="accent5" accent6="accent6" hlink="hlink" folHlink="folHlink"/>
   <p:sldLayoutIdLst>
@@ -4474,7 +4447,7 @@
         <a:spcBef>
           <a:spcPct val="20000"/>
         </a:spcBef>
-        <a:buFont typeface="Arial"/>
+        <a:buFont typeface="Arial" panose="020B0604020202020204"/>
         <a:buChar char="•"/>
         <a:defRPr sz="3200" kern="1200">
           <a:solidFill>
@@ -4489,7 +4462,7 @@
         <a:spcBef>
           <a:spcPct val="20000"/>
         </a:spcBef>
-        <a:buFont typeface="Arial"/>
+        <a:buFont typeface="Arial" panose="020B0604020202020204"/>
         <a:buChar char="–"/>
         <a:defRPr sz="2800" kern="1200">
           <a:solidFill>
@@ -4504,7 +4477,7 @@
         <a:spcBef>
           <a:spcPct val="20000"/>
         </a:spcBef>
-        <a:buFont typeface="Arial"/>
+        <a:buFont typeface="Arial" panose="020B0604020202020204"/>
         <a:buChar char="•"/>
         <a:defRPr sz="2400" kern="1200">
           <a:solidFill>
@@ -4519,7 +4492,7 @@
         <a:spcBef>
           <a:spcPct val="20000"/>
         </a:spcBef>
-        <a:buFont typeface="Arial"/>
+        <a:buFont typeface="Arial" panose="020B0604020202020204"/>
         <a:buChar char="–"/>
         <a:defRPr sz="2000" kern="1200">
           <a:solidFill>
@@ -4534,7 +4507,7 @@
         <a:spcBef>
           <a:spcPct val="20000"/>
         </a:spcBef>
-        <a:buFont typeface="Arial"/>
+        <a:buFont typeface="Arial" panose="020B0604020202020204"/>
         <a:buChar char="»"/>
         <a:defRPr sz="2000" kern="1200">
           <a:solidFill>
@@ -4549,7 +4522,7 @@
         <a:spcBef>
           <a:spcPct val="20000"/>
         </a:spcBef>
-        <a:buFont typeface="Arial"/>
+        <a:buFont typeface="Arial" panose="020B0604020202020204"/>
         <a:buChar char="•"/>
         <a:defRPr sz="2000" kern="1200">
           <a:solidFill>
@@ -4564,7 +4537,7 @@
         <a:spcBef>
           <a:spcPct val="20000"/>
         </a:spcBef>
-        <a:buFont typeface="Arial"/>
+        <a:buFont typeface="Arial" panose="020B0604020202020204"/>
         <a:buChar char="•"/>
         <a:defRPr sz="2000" kern="1200">
           <a:solidFill>
@@ -4579,7 +4552,7 @@
         <a:spcBef>
           <a:spcPct val="20000"/>
         </a:spcBef>
-        <a:buFont typeface="Arial"/>
+        <a:buFont typeface="Arial" panose="020B0604020202020204"/>
         <a:buChar char="•"/>
         <a:defRPr sz="2000" kern="1200">
           <a:solidFill>
@@ -4594,7 +4567,7 @@
         <a:spcBef>
           <a:spcPct val="20000"/>
         </a:spcBef>
-        <a:buFont typeface="Arial"/>
+        <a:buFont typeface="Arial" panose="020B0604020202020204"/>
         <a:buChar char="•"/>
         <a:defRPr sz="2000" kern="1200">
           <a:solidFill>
@@ -4706,7 +4679,7 @@
 </file>
 
 <file path=ppt/slides/slide1.xml><?xml version="1.0" encoding="utf-8"?>
-<p:sld xmlns:a="http://schemas.openxmlformats.org/drawingml/2006/main" xmlns:p="http://schemas.openxmlformats.org/presentationml/2006/main" xmlns:r="http://schemas.openxmlformats.org/officeDocument/2006/relationships">
+<p:sld xmlns:a="http://schemas.openxmlformats.org/drawingml/2006/main" xmlns:r="http://schemas.openxmlformats.org/officeDocument/2006/relationships" xmlns:p="http://schemas.openxmlformats.org/presentationml/2006/main">
   <p:cSld>
     <p:bg>
       <p:bgPr>
@@ -4889,7 +4862,7 @@
         <p:spPr>
           <a:xfrm>
             <a:off x="822960" y="2880360"/>
-            <a:ext cx="5669280" cy="2743200"/>
+            <a:ext cx="2416175" cy="1904365"/>
           </a:xfrm>
           <a:prstGeom prst="rect">
             <a:avLst/>
@@ -4903,7 +4876,7 @@
           <a:lstStyle/>
           <a:p>
             <a:pPr>
-              <a:defRPr b="1" sz="1300">
+              <a:defRPr sz="1300" b="1">
                 <a:solidFill>
                   <a:srgbClr val="86AEDE"/>
                 </a:solidFill>
@@ -4999,9 +4972,6 @@
                 </a:solidFill>
               </a:defRPr>
             </a:pPr>
-            <a:r>
-              <a:t>Mumba Adrian — 2611537</a:t>
-            </a:r>
           </a:p>
         </p:txBody>
       </p:sp>
@@ -5045,7 +5015,7 @@
           <a:lstStyle/>
           <a:p>
             <a:pPr algn="ctr">
-              <a:defRPr b="1" sz="1600">
+              <a:defRPr sz="1600" b="1">
                 <a:solidFill>
                   <a:srgbClr val="FFFFFF"/>
                 </a:solidFill>
@@ -5097,7 +5067,7 @@
           <a:lstStyle/>
           <a:p>
             <a:pPr algn="ctr">
-              <a:defRPr b="1" sz="1600">
+              <a:defRPr sz="1600" b="1">
                 <a:solidFill>
                   <a:srgbClr val="FFFFFF"/>
                 </a:solidFill>
@@ -5149,7 +5119,7 @@
           <a:lstStyle/>
           <a:p>
             <a:pPr algn="ctr">
-              <a:defRPr b="1" sz="1600">
+              <a:defRPr sz="1600" b="1">
                 <a:solidFill>
                   <a:srgbClr val="FFFFFF"/>
                 </a:solidFill>
@@ -5170,7 +5140,7 @@
 </file>
 
 <file path=ppt/slides/slide10.xml><?xml version="1.0" encoding="utf-8"?>
-<p:sld xmlns:a="http://schemas.openxmlformats.org/drawingml/2006/main" xmlns:p="http://schemas.openxmlformats.org/presentationml/2006/main" xmlns:r="http://schemas.openxmlformats.org/officeDocument/2006/relationships">
+<p:sld xmlns:a="http://schemas.openxmlformats.org/drawingml/2006/main" xmlns:r="http://schemas.openxmlformats.org/officeDocument/2006/relationships" xmlns:p="http://schemas.openxmlformats.org/presentationml/2006/main">
   <p:cSld>
     <p:bg>
       <p:bgPr>
@@ -5508,7 +5478,7 @@
           <a:lstStyle/>
           <a:p>
             <a:pPr algn="ctr">
-              <a:defRPr b="1" sz="1300">
+              <a:defRPr sz="1300" b="1">
                 <a:solidFill>
                   <a:srgbClr val="FFFFFF"/>
                 </a:solidFill>
@@ -5603,7 +5573,7 @@
           <a:lstStyle/>
           <a:p>
             <a:pPr algn="ctr">
-              <a:defRPr b="1" sz="1300">
+              <a:defRPr sz="1300" b="1">
                 <a:solidFill>
                   <a:srgbClr val="FFFFFF"/>
                 </a:solidFill>
@@ -5698,7 +5668,7 @@
           <a:lstStyle/>
           <a:p>
             <a:pPr algn="ctr">
-              <a:defRPr b="1" sz="1300">
+              <a:defRPr sz="1300" b="1">
                 <a:solidFill>
                   <a:srgbClr val="FFFFFF"/>
                 </a:solidFill>
@@ -5793,7 +5763,7 @@
           <a:lstStyle/>
           <a:p>
             <a:pPr algn="ctr">
-              <a:defRPr b="1" sz="1300">
+              <a:defRPr sz="1300" b="1">
                 <a:solidFill>
                   <a:srgbClr val="FFFFFF"/>
                 </a:solidFill>
@@ -5888,7 +5858,7 @@
           <a:lstStyle/>
           <a:p>
             <a:pPr algn="ctr">
-              <a:defRPr b="1" sz="1300">
+              <a:defRPr sz="1300" b="1">
                 <a:solidFill>
                   <a:srgbClr val="FFFFFF"/>
                 </a:solidFill>
@@ -5983,7 +5953,7 @@
           <a:lstStyle/>
           <a:p>
             <a:pPr algn="ctr">
-              <a:defRPr b="1" sz="1300">
+              <a:defRPr sz="1300" b="1">
                 <a:solidFill>
                   <a:srgbClr val="FFFFFF"/>
                 </a:solidFill>
@@ -6068,7 +6038,7 @@
           </a:fontRef>
         </p:style>
         <p:txBody>
-          <a:bodyPr rtlCol="0" anchor="ctr" lIns="228600" rIns="164592" tIns="164592" wrap="square"/>
+          <a:bodyPr wrap="square" lIns="228600" tIns="164592" rIns="164592" rtlCol="0" anchor="ctr"/>
           <a:lstStyle/>
           <a:p>
             <a:pPr algn="ctr">
@@ -6129,7 +6099,7 @@
 </file>
 
 <file path=ppt/slides/slide11.xml><?xml version="1.0" encoding="utf-8"?>
-<p:sld xmlns:a="http://schemas.openxmlformats.org/drawingml/2006/main" xmlns:p="http://schemas.openxmlformats.org/presentationml/2006/main" xmlns:r="http://schemas.openxmlformats.org/officeDocument/2006/relationships">
+<p:sld xmlns:a="http://schemas.openxmlformats.org/drawingml/2006/main" xmlns:r="http://schemas.openxmlformats.org/officeDocument/2006/relationships" xmlns:p="http://schemas.openxmlformats.org/presentationml/2006/main">
   <p:cSld>
     <p:bg>
       <p:bgPr>
@@ -6531,7 +6501,7 @@
           </a:fontRef>
         </p:style>
         <p:txBody>
-          <a:bodyPr rtlCol="0" anchor="ctr" lIns="228600" rIns="164592" tIns="164592" wrap="square"/>
+          <a:bodyPr wrap="square" lIns="228600" tIns="164592" rIns="164592" rtlCol="0" anchor="ctr"/>
           <a:lstStyle/>
           <a:p>
             <a:pPr algn="ctr">
@@ -6608,7 +6578,7 @@
 </file>
 
 <file path=ppt/slides/slide12.xml><?xml version="1.0" encoding="utf-8"?>
-<p:sld xmlns:a="http://schemas.openxmlformats.org/drawingml/2006/main" xmlns:p="http://schemas.openxmlformats.org/presentationml/2006/main" xmlns:r="http://schemas.openxmlformats.org/officeDocument/2006/relationships">
+<p:sld xmlns:a="http://schemas.openxmlformats.org/drawingml/2006/main" xmlns:r="http://schemas.openxmlformats.org/officeDocument/2006/relationships" xmlns:p="http://schemas.openxmlformats.org/presentationml/2006/main">
   <p:cSld>
     <p:bg>
       <p:bgPr>
@@ -6783,7 +6753,7 @@
           <p:nvPr/>
         </p:nvPicPr>
         <p:blipFill>
-          <a:blip r:embed="rId2"/>
+          <a:blip r:embed="rId1"/>
           <a:stretch>
             <a:fillRect/>
           </a:stretch>
@@ -6807,7 +6777,7 @@
           <p:nvPr/>
         </p:nvPicPr>
         <p:blipFill>
-          <a:blip r:embed="rId3"/>
+          <a:blip r:embed="rId2"/>
           <a:stretch>
             <a:fillRect/>
           </a:stretch>
@@ -6831,7 +6801,7 @@
           <p:nvPr/>
         </p:nvPicPr>
         <p:blipFill>
-          <a:blip r:embed="rId4"/>
+          <a:blip r:embed="rId3"/>
           <a:stretch>
             <a:fillRect/>
           </a:stretch>
@@ -6855,7 +6825,7 @@
           <p:nvPr/>
         </p:nvPicPr>
         <p:blipFill>
-          <a:blip r:embed="rId5"/>
+          <a:blip r:embed="rId4"/>
           <a:stretch>
             <a:fillRect/>
           </a:stretch>
@@ -6879,7 +6849,7 @@
 </file>
 
 <file path=ppt/slides/slide13.xml><?xml version="1.0" encoding="utf-8"?>
-<p:sld xmlns:a="http://schemas.openxmlformats.org/drawingml/2006/main" xmlns:p="http://schemas.openxmlformats.org/presentationml/2006/main" xmlns:r="http://schemas.openxmlformats.org/officeDocument/2006/relationships">
+<p:sld xmlns:a="http://schemas.openxmlformats.org/drawingml/2006/main" xmlns:r="http://schemas.openxmlformats.org/officeDocument/2006/relationships" xmlns:p="http://schemas.openxmlformats.org/presentationml/2006/main">
   <p:cSld>
     <p:bg>
       <p:bgPr>
@@ -7087,7 +7057,7 @@
           <a:lstStyle/>
           <a:p>
             <a:pPr algn="ctr">
-              <a:defRPr b="1" sz="1800">
+              <a:defRPr sz="1800" b="1">
                 <a:solidFill>
                   <a:srgbClr val="1F5BA8"/>
                 </a:solidFill>
@@ -7186,7 +7156,7 @@
           <a:lstStyle/>
           <a:p>
             <a:pPr algn="ctr">
-              <a:defRPr b="1" sz="1800">
+              <a:defRPr sz="1800" b="1">
                 <a:solidFill>
                   <a:srgbClr val="1E7841"/>
                 </a:solidFill>
@@ -7285,7 +7255,7 @@
           <a:lstStyle/>
           <a:p>
             <a:pPr algn="ctr">
-              <a:defRPr b="1" sz="1800">
+              <a:defRPr sz="1800" b="1">
                 <a:solidFill>
                   <a:srgbClr val="69309B"/>
                 </a:solidFill>
@@ -7351,7 +7321,7 @@
 </file>
 
 <file path=ppt/slides/slide14.xml><?xml version="1.0" encoding="utf-8"?>
-<p:sld xmlns:a="http://schemas.openxmlformats.org/drawingml/2006/main" xmlns:p="http://schemas.openxmlformats.org/presentationml/2006/main" xmlns:r="http://schemas.openxmlformats.org/officeDocument/2006/relationships">
+<p:sld xmlns:a="http://schemas.openxmlformats.org/drawingml/2006/main" xmlns:r="http://schemas.openxmlformats.org/officeDocument/2006/relationships" xmlns:p="http://schemas.openxmlformats.org/presentationml/2006/main">
   <p:cSld>
     <p:bg>
       <p:bgPr>
@@ -7753,7 +7723,7 @@
           </a:fontRef>
         </p:style>
         <p:txBody>
-          <a:bodyPr rtlCol="0" anchor="ctr" lIns="228600" rIns="164592" tIns="164592" wrap="square"/>
+          <a:bodyPr wrap="square" lIns="228600" tIns="164592" rIns="164592" rtlCol="0" anchor="ctr"/>
           <a:lstStyle/>
           <a:p>
             <a:pPr algn="ctr">
@@ -7846,7 +7816,7 @@
 </file>
 
 <file path=ppt/slides/slide15.xml><?xml version="1.0" encoding="utf-8"?>
-<p:sld xmlns:a="http://schemas.openxmlformats.org/drawingml/2006/main" xmlns:p="http://schemas.openxmlformats.org/presentationml/2006/main" xmlns:r="http://schemas.openxmlformats.org/officeDocument/2006/relationships">
+<p:sld xmlns:a="http://schemas.openxmlformats.org/drawingml/2006/main" xmlns:r="http://schemas.openxmlformats.org/officeDocument/2006/relationships" xmlns:p="http://schemas.openxmlformats.org/presentationml/2006/main">
   <p:cSld>
     <p:bg>
       <p:bgPr>
@@ -8050,7 +8020,7 @@
           </a:fontRef>
         </p:style>
         <p:txBody>
-          <a:bodyPr rtlCol="0" anchor="ctr" lIns="228600" rIns="164592" tIns="164592" wrap="square"/>
+          <a:bodyPr wrap="square" lIns="228600" tIns="164592" rIns="164592" rtlCol="0" anchor="ctr"/>
           <a:lstStyle/>
           <a:p>
             <a:pPr algn="ctr">
@@ -8143,7 +8113,7 @@
 </file>
 
 <file path=ppt/slides/slide16.xml><?xml version="1.0" encoding="utf-8"?>
-<p:sld xmlns:a="http://schemas.openxmlformats.org/drawingml/2006/main" xmlns:p="http://schemas.openxmlformats.org/presentationml/2006/main" xmlns:r="http://schemas.openxmlformats.org/officeDocument/2006/relationships">
+<p:sld xmlns:a="http://schemas.openxmlformats.org/drawingml/2006/main" xmlns:r="http://schemas.openxmlformats.org/officeDocument/2006/relationships" xmlns:p="http://schemas.openxmlformats.org/presentationml/2006/main">
   <p:cSld>
     <p:bg>
       <p:bgPr>
@@ -8351,7 +8321,7 @@
           <a:lstStyle/>
           <a:p>
             <a:pPr algn="ctr">
-              <a:defRPr b="1" sz="1500">
+              <a:defRPr sz="1500" b="1">
                 <a:solidFill>
                   <a:srgbClr val="0C2A5B"/>
                 </a:solidFill>
@@ -8417,7 +8387,7 @@
           <a:lstStyle/>
           <a:p>
             <a:pPr algn="ctr">
-              <a:defRPr b="1" sz="1500">
+              <a:defRPr sz="1500" b="1">
                 <a:solidFill>
                   <a:srgbClr val="0C2A5B"/>
                 </a:solidFill>
@@ -8483,7 +8453,7 @@
           <a:lstStyle/>
           <a:p>
             <a:pPr algn="ctr">
-              <a:defRPr b="1" sz="1500">
+              <a:defRPr sz="1500" b="1">
                 <a:solidFill>
                   <a:srgbClr val="0C2A5B"/>
                 </a:solidFill>
@@ -8549,7 +8519,7 @@
           <a:lstStyle/>
           <a:p>
             <a:pPr algn="ctr">
-              <a:defRPr b="1" sz="1500">
+              <a:defRPr sz="1500" b="1">
                 <a:solidFill>
                   <a:srgbClr val="0C2A5B"/>
                 </a:solidFill>
@@ -8615,7 +8585,7 @@
           <a:lstStyle/>
           <a:p>
             <a:pPr algn="ctr">
-              <a:defRPr b="1" sz="1500">
+              <a:defRPr sz="1500" b="1">
                 <a:solidFill>
                   <a:srgbClr val="0C2A5B"/>
                 </a:solidFill>
@@ -8681,7 +8651,7 @@
           <a:lstStyle/>
           <a:p>
             <a:pPr algn="ctr">
-              <a:defRPr b="1" sz="1500">
+              <a:defRPr sz="1500" b="1">
                 <a:solidFill>
                   <a:srgbClr val="0C2A5B"/>
                 </a:solidFill>
@@ -8747,7 +8717,7 @@
           <a:lstStyle/>
           <a:p>
             <a:pPr algn="ctr">
-              <a:defRPr b="1" sz="1500">
+              <a:defRPr sz="1500" b="1">
                 <a:solidFill>
                   <a:srgbClr val="0C2A5B"/>
                 </a:solidFill>
@@ -8780,7 +8750,7 @@
 </file>
 
 <file path=ppt/slides/slide17.xml><?xml version="1.0" encoding="utf-8"?>
-<p:sld xmlns:a="http://schemas.openxmlformats.org/drawingml/2006/main" xmlns:p="http://schemas.openxmlformats.org/presentationml/2006/main" xmlns:r="http://schemas.openxmlformats.org/officeDocument/2006/relationships">
+<p:sld xmlns:a="http://schemas.openxmlformats.org/drawingml/2006/main" xmlns:r="http://schemas.openxmlformats.org/officeDocument/2006/relationships" xmlns:p="http://schemas.openxmlformats.org/presentationml/2006/main">
   <p:cSld>
     <p:bg>
       <p:bgPr>
@@ -8986,7 +8956,7 @@
           <a:lstStyle/>
           <a:p>
             <a:pPr algn="ctr">
-              <a:defRPr b="1" sz="1500">
+              <a:defRPr sz="1500" b="1">
                 <a:solidFill>
                   <a:srgbClr val="FFFFFF"/>
                 </a:solidFill>
@@ -9038,7 +9008,7 @@
           <a:lstStyle/>
           <a:p>
             <a:pPr algn="ctr">
-              <a:defRPr b="1" sz="1500">
+              <a:defRPr sz="1500" b="1">
                 <a:solidFill>
                   <a:srgbClr val="FFFFFF"/>
                 </a:solidFill>
@@ -9090,7 +9060,7 @@
           <a:lstStyle/>
           <a:p>
             <a:pPr algn="ctr">
-              <a:defRPr b="1" sz="1500">
+              <a:defRPr sz="1500" b="1">
                 <a:solidFill>
                   <a:srgbClr val="FFFFFF"/>
                 </a:solidFill>
@@ -9142,7 +9112,7 @@
           <a:lstStyle/>
           <a:p>
             <a:pPr algn="ctr">
-              <a:defRPr b="1" sz="1500">
+              <a:defRPr sz="1500" b="1">
                 <a:solidFill>
                   <a:srgbClr val="FFFFFF"/>
                 </a:solidFill>
@@ -9194,7 +9164,7 @@
           <a:lstStyle/>
           <a:p>
             <a:pPr algn="ctr">
-              <a:defRPr b="1" sz="1500">
+              <a:defRPr sz="1500" b="1">
                 <a:solidFill>
                   <a:srgbClr val="FFFFFF"/>
                 </a:solidFill>
@@ -9246,7 +9216,7 @@
           <a:lstStyle/>
           <a:p>
             <a:pPr algn="ctr">
-              <a:defRPr b="1" sz="1500">
+              <a:defRPr sz="1500" b="1">
                 <a:solidFill>
                   <a:srgbClr val="FFFFFF"/>
                 </a:solidFill>
@@ -9298,7 +9268,7 @@
           <a:lstStyle/>
           <a:p>
             <a:pPr algn="ctr">
-              <a:defRPr b="1" sz="1500">
+              <a:defRPr sz="1500" b="1">
                 <a:solidFill>
                   <a:srgbClr val="FFFFFF"/>
                 </a:solidFill>
@@ -9350,7 +9320,7 @@
           <a:lstStyle/>
           <a:p>
             <a:pPr algn="ctr">
-              <a:defRPr b="1" sz="1500">
+              <a:defRPr sz="1500" b="1">
                 <a:solidFill>
                   <a:srgbClr val="FFFFFF"/>
                 </a:solidFill>
@@ -9406,7 +9376,7 @@
 </file>
 
 <file path=ppt/slides/slide18.xml><?xml version="1.0" encoding="utf-8"?>
-<p:sld xmlns:a="http://schemas.openxmlformats.org/drawingml/2006/main" xmlns:p="http://schemas.openxmlformats.org/presentationml/2006/main" xmlns:r="http://schemas.openxmlformats.org/officeDocument/2006/relationships">
+<p:sld xmlns:a="http://schemas.openxmlformats.org/drawingml/2006/main" xmlns:r="http://schemas.openxmlformats.org/officeDocument/2006/relationships" xmlns:p="http://schemas.openxmlformats.org/presentationml/2006/main">
   <p:cSld>
     <p:bg>
       <p:bgPr>
@@ -9546,7 +9516,7 @@
 </file>
 
 <file path=ppt/slides/slide2.xml><?xml version="1.0" encoding="utf-8"?>
-<p:sld xmlns:a="http://schemas.openxmlformats.org/drawingml/2006/main" xmlns:p="http://schemas.openxmlformats.org/presentationml/2006/main" xmlns:r="http://schemas.openxmlformats.org/officeDocument/2006/relationships">
+<p:sld xmlns:a="http://schemas.openxmlformats.org/drawingml/2006/main" xmlns:r="http://schemas.openxmlformats.org/officeDocument/2006/relationships" xmlns:p="http://schemas.openxmlformats.org/presentationml/2006/main">
   <p:cSld>
     <p:bg>
       <p:bgPr>
@@ -9750,7 +9720,7 @@
           </a:fontRef>
         </p:style>
         <p:txBody>
-          <a:bodyPr rtlCol="0" anchor="ctr" lIns="228600" rIns="164592" tIns="164592" wrap="square"/>
+          <a:bodyPr wrap="square" lIns="228600" tIns="164592" rIns="164592" rtlCol="0" anchor="ctr"/>
           <a:lstStyle/>
           <a:p>
             <a:pPr algn="ctr">
@@ -10025,7 +9995,7 @@
 </file>
 
 <file path=ppt/slides/slide3.xml><?xml version="1.0" encoding="utf-8"?>
-<p:sld xmlns:a="http://schemas.openxmlformats.org/drawingml/2006/main" xmlns:p="http://schemas.openxmlformats.org/presentationml/2006/main" xmlns:r="http://schemas.openxmlformats.org/officeDocument/2006/relationships">
+<p:sld xmlns:a="http://schemas.openxmlformats.org/drawingml/2006/main" xmlns:r="http://schemas.openxmlformats.org/officeDocument/2006/relationships" xmlns:p="http://schemas.openxmlformats.org/presentationml/2006/main">
   <p:cSld>
     <p:bg>
       <p:bgPr>
@@ -10229,7 +10199,7 @@
           </a:fontRef>
         </p:style>
         <p:txBody>
-          <a:bodyPr rtlCol="0" anchor="ctr" lIns="228600" rIns="164592" tIns="164592" wrap="square"/>
+          <a:bodyPr wrap="square" lIns="228600" tIns="164592" rIns="164592" rtlCol="0" anchor="ctr"/>
           <a:lstStyle/>
           <a:p>
             <a:pPr algn="ctr">
@@ -10370,7 +10340,7 @@
 </file>
 
 <file path=ppt/slides/slide4.xml><?xml version="1.0" encoding="utf-8"?>
-<p:sld xmlns:a="http://schemas.openxmlformats.org/drawingml/2006/main" xmlns:p="http://schemas.openxmlformats.org/presentationml/2006/main" xmlns:r="http://schemas.openxmlformats.org/officeDocument/2006/relationships">
+<p:sld xmlns:a="http://schemas.openxmlformats.org/drawingml/2006/main" xmlns:r="http://schemas.openxmlformats.org/officeDocument/2006/relationships" xmlns:p="http://schemas.openxmlformats.org/presentationml/2006/main">
   <p:cSld>
     <p:bg>
       <p:bgPr>
@@ -10578,7 +10548,7 @@
           <a:lstStyle/>
           <a:p>
             <a:pPr algn="ctr">
-              <a:defRPr b="1" sz="2000">
+              <a:defRPr sz="2000" b="1">
                 <a:solidFill>
                   <a:srgbClr val="1F5BA8"/>
                 </a:solidFill>
@@ -10644,7 +10614,7 @@
           <a:lstStyle/>
           <a:p>
             <a:pPr algn="ctr">
-              <a:defRPr b="1" sz="2000">
+              <a:defRPr sz="2000" b="1">
                 <a:solidFill>
                   <a:srgbClr val="69309B"/>
                 </a:solidFill>
@@ -10710,7 +10680,7 @@
           <a:lstStyle/>
           <a:p>
             <a:pPr algn="ctr">
-              <a:defRPr b="1" sz="2000">
+              <a:defRPr sz="2000" b="1">
                 <a:solidFill>
                   <a:srgbClr val="1E7841"/>
                 </a:solidFill>
@@ -10776,7 +10746,7 @@
           <a:lstStyle/>
           <a:p>
             <a:pPr algn="ctr">
-              <a:defRPr b="1" sz="2000">
+              <a:defRPr sz="2000" b="1">
                 <a:solidFill>
                   <a:srgbClr val="D56F0F"/>
                 </a:solidFill>
@@ -10842,7 +10812,7 @@
           <a:lstStyle/>
           <a:p>
             <a:pPr algn="ctr">
-              <a:defRPr b="1" sz="2000">
+              <a:defRPr sz="2000" b="1">
                 <a:solidFill>
                   <a:srgbClr val="BE2D2D"/>
                 </a:solidFill>
@@ -10908,7 +10878,7 @@
           <a:lstStyle/>
           <a:p>
             <a:pPr algn="ctr">
-              <a:defRPr b="1" sz="2000">
+              <a:defRPr sz="2000" b="1">
                 <a:solidFill>
                   <a:srgbClr val="1F5BA8"/>
                 </a:solidFill>
@@ -10974,7 +10944,7 @@
           <a:lstStyle/>
           <a:p>
             <a:pPr algn="ctr">
-              <a:defRPr b="1" sz="2000">
+              <a:defRPr sz="2000" b="1">
                 <a:solidFill>
                   <a:srgbClr val="505B69"/>
                 </a:solidFill>
@@ -11007,7 +10977,7 @@
 </file>
 
 <file path=ppt/slides/slide5.xml><?xml version="1.0" encoding="utf-8"?>
-<p:sld xmlns:a="http://schemas.openxmlformats.org/drawingml/2006/main" xmlns:p="http://schemas.openxmlformats.org/presentationml/2006/main" xmlns:r="http://schemas.openxmlformats.org/officeDocument/2006/relationships">
+<p:sld xmlns:a="http://schemas.openxmlformats.org/drawingml/2006/main" xmlns:r="http://schemas.openxmlformats.org/officeDocument/2006/relationships" xmlns:p="http://schemas.openxmlformats.org/presentationml/2006/main">
   <p:cSld>
     <p:bg>
       <p:bgPr>
@@ -11182,7 +11152,7 @@
           <p:nvPr/>
         </p:nvPicPr>
         <p:blipFill>
-          <a:blip r:embed="rId2"/>
+          <a:blip r:embed="rId1"/>
           <a:stretch>
             <a:fillRect/>
           </a:stretch>
@@ -11206,7 +11176,7 @@
 </file>
 
 <file path=ppt/slides/slide6.xml><?xml version="1.0" encoding="utf-8"?>
-<p:sld xmlns:a="http://schemas.openxmlformats.org/drawingml/2006/main" xmlns:p="http://schemas.openxmlformats.org/presentationml/2006/main" xmlns:r="http://schemas.openxmlformats.org/officeDocument/2006/relationships">
+<p:sld xmlns:a="http://schemas.openxmlformats.org/drawingml/2006/main" xmlns:r="http://schemas.openxmlformats.org/officeDocument/2006/relationships" xmlns:p="http://schemas.openxmlformats.org/presentationml/2006/main">
   <p:cSld>
     <p:bg>
       <p:bgPr>
@@ -11381,7 +11351,7 @@
           <p:nvPr/>
         </p:nvPicPr>
         <p:blipFill>
-          <a:blip r:embed="rId2"/>
+          <a:blip r:embed="rId1"/>
           <a:stretch>
             <a:fillRect/>
           </a:stretch>
@@ -11405,7 +11375,7 @@
 </file>
 
 <file path=ppt/slides/slide7.xml><?xml version="1.0" encoding="utf-8"?>
-<p:sld xmlns:a="http://schemas.openxmlformats.org/drawingml/2006/main" xmlns:p="http://schemas.openxmlformats.org/presentationml/2006/main" xmlns:r="http://schemas.openxmlformats.org/officeDocument/2006/relationships">
+<p:sld xmlns:a="http://schemas.openxmlformats.org/drawingml/2006/main" xmlns:r="http://schemas.openxmlformats.org/officeDocument/2006/relationships" xmlns:p="http://schemas.openxmlformats.org/presentationml/2006/main">
   <p:cSld>
     <p:bg>
       <p:bgPr>
@@ -12445,7 +12415,7 @@
 </file>
 
 <file path=ppt/slides/slide8.xml><?xml version="1.0" encoding="utf-8"?>
-<p:sld xmlns:a="http://schemas.openxmlformats.org/drawingml/2006/main" xmlns:p="http://schemas.openxmlformats.org/presentationml/2006/main" xmlns:r="http://schemas.openxmlformats.org/officeDocument/2006/relationships">
+<p:sld xmlns:a="http://schemas.openxmlformats.org/drawingml/2006/main" xmlns:r="http://schemas.openxmlformats.org/officeDocument/2006/relationships" xmlns:p="http://schemas.openxmlformats.org/presentationml/2006/main">
   <p:cSld>
     <p:bg>
       <p:bgPr>
@@ -12847,7 +12817,7 @@
           </a:fontRef>
         </p:style>
         <p:txBody>
-          <a:bodyPr rtlCol="0" anchor="ctr" lIns="228600" rIns="164592" tIns="164592" wrap="square"/>
+          <a:bodyPr wrap="square" lIns="228600" tIns="164592" rIns="164592" rtlCol="0" anchor="ctr"/>
           <a:lstStyle/>
           <a:p>
             <a:pPr algn="ctr">
@@ -12924,7 +12894,7 @@
 </file>
 
 <file path=ppt/slides/slide9.xml><?xml version="1.0" encoding="utf-8"?>
-<p:sld xmlns:a="http://schemas.openxmlformats.org/drawingml/2006/main" xmlns:p="http://schemas.openxmlformats.org/presentationml/2006/main" xmlns:r="http://schemas.openxmlformats.org/officeDocument/2006/relationships">
+<p:sld xmlns:a="http://schemas.openxmlformats.org/drawingml/2006/main" xmlns:r="http://schemas.openxmlformats.org/officeDocument/2006/relationships" xmlns:p="http://schemas.openxmlformats.org/presentationml/2006/main">
   <p:cSld>
     <p:bg>
       <p:bgPr>
@@ -13260,7 +13230,7 @@
           </a:fontRef>
         </p:style>
         <p:txBody>
-          <a:bodyPr rtlCol="0" anchor="ctr" lIns="228600" rIns="164592" tIns="164592" wrap="square"/>
+          <a:bodyPr wrap="square" lIns="228600" tIns="164592" rIns="164592" rtlCol="0" anchor="ctr"/>
           <a:lstStyle/>
           <a:p>
             <a:pPr algn="ctr">
@@ -13370,7 +13340,7 @@
           <a:lstStyle/>
           <a:p>
             <a:pPr algn="ctr">
-              <a:defRPr b="1" sz="1800">
+              <a:defRPr sz="1800" b="1">
                 <a:solidFill>
                   <a:srgbClr val="0C2A5B"/>
                 </a:solidFill>
@@ -13718,7 +13688,11 @@
       </a:style>
     </a:lnDef>
   </a:objectDefaults>
-  <a:extraClrSchemeLst/>
+  <a:extLst>
+    <a:ext uri="{05A4C25C-085E-4340-85A3-A5531E510DB2}">
+      <thm15:themeFamily xmlns:thm15="http://schemas.microsoft.com/office/thememl/2012/main" name="Office Theme" id="{62F939B6-93AF-4DB8-9C6B-D6C7DFDC589F}" vid="{4A3C46E8-61CC-4603-A589-7422A47A8E4A}"/>
+    </a:ext>
+  </a:extLst>
 </a:theme>
 </file>
 
@@ -14038,6 +14012,10 @@
       </a:style>
     </a:lnDef>
   </a:objectDefaults>
-  <a:extraClrSchemeLst/>
+  <a:extLst>
+    <a:ext uri="{05A4C25C-085E-4340-85A3-A5531E510DB2}">
+      <thm15:themeFamily xmlns:thm15="http://schemas.microsoft.com/office/thememl/2012/main" name="Office Theme" id="{62F939B6-93AF-4DB8-9C6B-D6C7DFDC589F}" vid="{4A3C46E8-61CC-4603-A589-7422A47A8E4A}"/>
+    </a:ext>
+  </a:extLst>
 </a:theme>
 </file>
</xml_diff>